<commit_message>
Deck: apply review edits (49 states + DC, manual NC collection on timeline, fare-free stat, wording); dashboard: count DC separately from states
Co-Authored-By: Claude Fable 5.1 <noreply@anthropic.com>
</commit_message>
<xml_diff>
--- a/docs/ODT-Database-Project-Summary.pptx
+++ b/docs/ODT-Database-Project-Summary.pptx
@@ -1395,7 +1395,7 @@
           <a:lstStyle/>
           <a:p>
             <a:r>
-              <a:t>The 1,063 number is worth pausing on: every removal, correction and unverified field has a written entry with a citation. That log is the audit trail for the whole inventory.</a:t>
+              <a:t>Fare-free is the most audience-friendly number: 174 systems charge nothing, typically funded by municipal or federal grants. Also worth mentioning: every removal, correction and unverified field has a written entry in concerns.csv, 1,063 entries so far, which is the audit trail for the whole inventory.</a:t>
             </a:r>
           </a:p>
         </p:txBody>
@@ -38752,7 +38752,7 @@
         </p:spPr>
         <p:txBody>
           <a:bodyPr wrap="square" anchor="t" lIns="109728" tIns="91440" rIns="109728" bIns="91440">
-            <a:spAutoFit/>
+            <a:noAutofit/>
           </a:bodyPr>
           <a:lstStyle/>
           <a:p>
@@ -38814,7 +38814,7 @@
         </p:spPr>
         <p:txBody>
           <a:bodyPr wrap="square" anchor="t" lIns="109728" tIns="91440" rIns="109728" bIns="91440">
-            <a:spAutoFit/>
+            <a:noAutofit/>
           </a:bodyPr>
           <a:lstStyle/>
           <a:p>
@@ -38848,7 +38848,7 @@
                 </a:solidFill>
                 <a:latin typeface="Arial"/>
               </a:rPr>
-              <a:t>Propulsion and accessibility charts count text mentions, not fleet audits. "Not mentioned" is a gap in the source, not evidence of absence.</a:t>
+              <a:t>The dashboard's fleet-propulsion and accessibility charts count keyword mentions in the Fleet and Notes fields, not fleet audits. "Not mentioned" is a gap in the source, not evidence of absence.</a:t>
             </a:r>
           </a:p>
         </p:txBody>
@@ -38874,7 +38874,7 @@
         </p:spPr>
         <p:txBody>
           <a:bodyPr wrap="square" anchor="t" lIns="109728" tIns="91440" rIns="109728" bIns="91440">
-            <a:spAutoFit/>
+            <a:noAutofit/>
           </a:bodyPr>
           <a:lstStyle/>
           <a:p>
@@ -38958,7 +38958,7 @@
         </p:spPr>
         <p:txBody>
           <a:bodyPr wrap="square" anchor="t" lIns="109728" tIns="91440" rIns="109728" bIns="91440">
-            <a:spAutoFit/>
+            <a:noAutofit/>
           </a:bodyPr>
           <a:lstStyle/>
           <a:p>
@@ -39020,7 +39020,7 @@
         </p:spPr>
         <p:txBody>
           <a:bodyPr wrap="square" anchor="t" lIns="109728" tIns="91440" rIns="109728" bIns="91440">
-            <a:spAutoFit/>
+            <a:noAutofit/>
           </a:bodyPr>
           <a:lstStyle/>
           <a:p>
@@ -39082,7 +39082,7 @@
         </p:spPr>
         <p:txBody>
           <a:bodyPr wrap="square" anchor="t" lIns="109728" tIns="91440" rIns="109728" bIns="91440">
-            <a:spAutoFit/>
+            <a:noAutofit/>
           </a:bodyPr>
           <a:lstStyle/>
           <a:p>
@@ -39144,7 +39144,7 @@
         </p:spPr>
         <p:txBody>
           <a:bodyPr wrap="square" anchor="t" lIns="109728" tIns="91440" rIns="109728" bIns="91440">
-            <a:spAutoFit/>
+            <a:noAutofit/>
           </a:bodyPr>
           <a:lstStyle/>
           <a:p>
@@ -39206,7 +39206,7 @@
         </p:spPr>
         <p:txBody>
           <a:bodyPr wrap="square" anchor="t" lIns="109728" tIns="91440" rIns="109728" bIns="91440">
-            <a:spAutoFit/>
+            <a:noAutofit/>
           </a:bodyPr>
           <a:lstStyle/>
           <a:p>
@@ -39268,7 +39268,7 @@
         </p:spPr>
         <p:txBody>
           <a:bodyPr wrap="square" anchor="t" lIns="109728" tIns="91440" rIns="109728" bIns="91440">
-            <a:spAutoFit/>
+            <a:noAutofit/>
           </a:bodyPr>
           <a:lstStyle/>
           <a:p>
@@ -39328,7 +39328,7 @@
         </p:spPr>
         <p:txBody>
           <a:bodyPr wrap="square" anchor="t" lIns="109728" tIns="91440" rIns="109728" bIns="91440">
-            <a:spAutoFit/>
+            <a:noAutofit/>
           </a:bodyPr>
           <a:lstStyle/>
           <a:p>
@@ -39893,7 +39893,7 @@
         </p:spPr>
         <p:txBody>
           <a:bodyPr wrap="square" anchor="t" lIns="109728" tIns="91440" rIns="109728" bIns="91440">
-            <a:spAutoFit/>
+            <a:noAutofit/>
           </a:bodyPr>
           <a:lstStyle/>
           <a:p>
@@ -39955,7 +39955,7 @@
         </p:spPr>
         <p:txBody>
           <a:bodyPr wrap="square" anchor="t" lIns="109728" tIns="91440" rIns="109728" bIns="91440">
-            <a:spAutoFit/>
+            <a:noAutofit/>
           </a:bodyPr>
           <a:lstStyle/>
           <a:p>
@@ -40017,7 +40017,7 @@
         </p:spPr>
         <p:txBody>
           <a:bodyPr wrap="square" anchor="t" lIns="109728" tIns="91440" rIns="109728" bIns="91440">
-            <a:spAutoFit/>
+            <a:noAutofit/>
           </a:bodyPr>
           <a:lstStyle/>
           <a:p>
@@ -40079,7 +40079,7 @@
         </p:spPr>
         <p:txBody>
           <a:bodyPr wrap="square" anchor="t" lIns="109728" tIns="91440" rIns="109728" bIns="91440">
-            <a:spAutoFit/>
+            <a:noAutofit/>
           </a:bodyPr>
           <a:lstStyle/>
           <a:p>
@@ -40141,7 +40141,7 @@
         </p:spPr>
         <p:txBody>
           <a:bodyPr wrap="square" anchor="ctr" lIns="109728" tIns="91440" rIns="109728" bIns="91440">
-            <a:spAutoFit/>
+            <a:noAutofit/>
           </a:bodyPr>
           <a:lstStyle/>
           <a:p>
@@ -40193,7 +40193,7 @@
         </p:spPr>
         <p:txBody>
           <a:bodyPr wrap="square" anchor="t" lIns="109728" tIns="91440" rIns="109728" bIns="91440">
-            <a:spAutoFit/>
+            <a:noAutofit/>
           </a:bodyPr>
           <a:lstStyle/>
           <a:p>
@@ -40455,7 +40455,7 @@
         </p:spPr>
         <p:txBody>
           <a:bodyPr wrap="square" anchor="t" lIns="109728" tIns="91440" rIns="109728" bIns="91440">
-            <a:spAutoFit/>
+            <a:noAutofit/>
           </a:bodyPr>
           <a:lstStyle/>
           <a:p>
@@ -40534,7 +40534,7 @@
         </p:spPr>
         <p:txBody>
           <a:bodyPr wrap="square" anchor="t" lIns="109728" tIns="91440" rIns="109728" bIns="91440">
-            <a:spAutoFit/>
+            <a:noAutofit/>
           </a:bodyPr>
           <a:lstStyle/>
           <a:p>
@@ -40551,7 +40551,7 @@
                 </a:solidFill>
                 <a:latin typeface="Arial"/>
               </a:rPr>
-              <a:t>50 + DC</a:t>
+              <a:t>49 + DC</a:t>
             </a:r>
           </a:p>
           <a:p>
@@ -40585,7 +40585,7 @@
                 </a:solidFill>
                 <a:latin typeface="Arial"/>
               </a:rPr>
-              <a:t>Every state has at least one row; California has the most at 94</a:t>
+              <a:t>Every state except Alaska has at least one system; California has the most at 94</a:t>
             </a:r>
           </a:p>
         </p:txBody>
@@ -40613,7 +40613,7 @@
         </p:spPr>
         <p:txBody>
           <a:bodyPr wrap="square" anchor="t" lIns="109728" tIns="91440" rIns="109728" bIns="91440">
-            <a:spAutoFit/>
+            <a:noAutofit/>
           </a:bodyPr>
           <a:lstStyle/>
           <a:p>
@@ -40690,7 +40690,7 @@
         </p:spPr>
         <p:txBody>
           <a:bodyPr wrap="square" anchor="t" lIns="109728" tIns="91440" rIns="109728" bIns="91440">
-            <a:spAutoFit/>
+            <a:noAutofit/>
           </a:bodyPr>
           <a:lstStyle/>
           <a:p>
@@ -40750,7 +40750,7 @@
         </p:spPr>
         <p:txBody>
           <a:bodyPr wrap="square" anchor="t" lIns="109728" tIns="91440" rIns="109728" bIns="91440">
-            <a:spAutoFit/>
+            <a:noAutofit/>
           </a:bodyPr>
           <a:lstStyle/>
           <a:p>
@@ -40810,7 +40810,7 @@
         </p:spPr>
         <p:txBody>
           <a:bodyPr wrap="square" anchor="t" lIns="109728" tIns="91440" rIns="109728" bIns="91440">
-            <a:spAutoFit/>
+            <a:noAutofit/>
           </a:bodyPr>
           <a:lstStyle/>
           <a:p>
@@ -40870,7 +40870,7 @@
         </p:spPr>
         <p:txBody>
           <a:bodyPr wrap="square" anchor="t" lIns="109728" tIns="91440" rIns="109728" bIns="91440">
-            <a:spAutoFit/>
+            <a:noAutofit/>
           </a:bodyPr>
           <a:lstStyle/>
           <a:p>
@@ -40887,7 +40887,7 @@
                 </a:solidFill>
                 <a:latin typeface="Arial"/>
               </a:rPr>
-              <a:t>1,063</a:t>
+              <a:t>26%</a:t>
             </a:r>
           </a:p>
           <a:p>
@@ -40904,7 +40904,7 @@
                 </a:solidFill>
                 <a:latin typeface="Arial"/>
               </a:rPr>
-              <a:t>Logged data decisions</a:t>
+              <a:t>Fare-free (174 systems)</a:t>
             </a:r>
           </a:p>
         </p:txBody>
@@ -40930,7 +40930,7 @@
         </p:spPr>
         <p:txBody>
           <a:bodyPr wrap="square" anchor="t" lIns="109728" tIns="91440" rIns="109728" bIns="91440">
-            <a:spAutoFit/>
+            <a:noAutofit/>
           </a:bodyPr>
           <a:lstStyle/>
           <a:p>
@@ -40947,7 +40947,7 @@
                 </a:solidFill>
                 <a:latin typeface="Arial"/>
               </a:rPr>
-              <a:t>Counts as of the 17 September 2026 build. "Logged decisions" are entries in concerns.csv, the project's change and caveat log.</a:t>
+              <a:t>Counts as of the 17 September 2026 build. Alaska is the one state with no qualifying system: all three candidates required day-before booking.</a:t>
             </a:r>
           </a:p>
         </p:txBody>
@@ -41304,7 +41304,7 @@
         </p:spPr>
         <p:txBody>
           <a:bodyPr wrap="square" anchor="t" lIns="109728" tIns="91440" rIns="109728" bIns="91440">
-            <a:spAutoFit/>
+            <a:noAutofit/>
           </a:bodyPr>
           <a:lstStyle/>
           <a:p>
@@ -41633,7 +41633,7 @@
         </p:spPr>
         <p:txBody>
           <a:bodyPr wrap="square" anchor="t" lIns="109728" tIns="91440" rIns="109728" bIns="91440">
-            <a:spAutoFit/>
+            <a:noAutofit/>
           </a:bodyPr>
           <a:lstStyle/>
           <a:p>
@@ -41703,7 +41703,127 @@
         <p:spPr>
           <a:xfrm>
             <a:off x="457200" y="1097280"/>
-            <a:ext cx="1517904" cy="54864"/>
+            <a:ext cx="1280160" cy="54864"/>
+          </a:xfrm>
+          <a:prstGeom prst="rect">
+            <a:avLst/>
+          </a:prstGeom>
+          <a:solidFill>
+            <a:srgbClr val="819E7E"/>
+          </a:solidFill>
+          <a:ln>
+            <a:noFill/>
+          </a:ln>
+        </p:spPr>
+        <p:style>
+          <a:lnRef idx="1">
+            <a:schemeClr val="accent1"/>
+          </a:lnRef>
+          <a:fillRef idx="3">
+            <a:schemeClr val="accent1"/>
+          </a:fillRef>
+          <a:effectRef idx="2">
+            <a:schemeClr val="accent1"/>
+          </a:effectRef>
+          <a:fontRef idx="minor">
+            <a:schemeClr val="lt1"/>
+          </a:fontRef>
+        </p:style>
+        <p:txBody>
+          <a:bodyPr rtlCol="0" anchor="ctr"/>
+          <a:lstStyle/>
+          <a:p>
+            <a:pPr algn="ctr"/>
+          </a:p>
+        </p:txBody>
+      </p:sp>
+      <p:sp>
+        <p:nvSpPr>
+          <p:cNvPr id="4" name="TextBox 3"/>
+          <p:cNvSpPr txBox="1"/>
+          <p:nvPr/>
+        </p:nvSpPr>
+        <p:spPr>
+          <a:xfrm>
+            <a:off x="457200" y="1188720"/>
+            <a:ext cx="1280160" cy="2377440"/>
+          </a:xfrm>
+          <a:prstGeom prst="rect">
+            <a:avLst/>
+          </a:prstGeom>
+          <a:noFill/>
+          <a:ln>
+            <a:noFill/>
+          </a:ln>
+        </p:spPr>
+        <p:txBody>
+          <a:bodyPr wrap="square" anchor="t" lIns="18288" tIns="54864" rIns="54864" bIns="36576">
+            <a:noAutofit/>
+          </a:bodyPr>
+          <a:lstStyle/>
+          <a:p>
+            <a:pPr marL="0" indent="0">
+              <a:spcAft>
+                <a:spcPts val="200"/>
+              </a:spcAft>
+              <a:buNone/>
+            </a:pPr>
+            <a:r>
+              <a:rPr sz="800" b="1" i="0">
+                <a:solidFill>
+                  <a:srgbClr val="819E7E"/>
+                </a:solidFill>
+                <a:latin typeface="Arial"/>
+              </a:rPr>
+              <a:t>BEFORE JUNE 2026</a:t>
+            </a:r>
+          </a:p>
+          <a:p>
+            <a:pPr marL="0" indent="0">
+              <a:spcAft>
+                <a:spcPts val="400"/>
+              </a:spcAft>
+              <a:buNone/>
+            </a:pPr>
+            <a:r>
+              <a:rPr sz="1150" b="1" i="0">
+                <a:solidFill>
+                  <a:srgbClr val="1F1F1F"/>
+                </a:solidFill>
+                <a:latin typeface="Arial"/>
+              </a:rPr>
+              <a:t>Manual NC collection</a:t>
+            </a:r>
+          </a:p>
+          <a:p>
+            <a:pPr marL="0" indent="0">
+              <a:spcAft>
+                <a:spcPts val="400"/>
+              </a:spcAft>
+              <a:buNone/>
+            </a:pPr>
+            <a:r>
+              <a:rPr sz="900" b="0" i="0">
+                <a:solidFill>
+                  <a:srgbClr val="4A4A4A"/>
+                </a:solidFill>
+                <a:latin typeface="Arial"/>
+              </a:rPr>
+              <a:t>North Carolina systems researched and entered by hand, one agency at a time, with service areas digitized manually. The model for every later row.</a:t>
+            </a:r>
+          </a:p>
+        </p:txBody>
+      </p:sp>
+      <p:sp>
+        <p:nvSpPr>
+          <p:cNvPr id="5" name="Rectangle 4"/>
+          <p:cNvSpPr/>
+          <p:nvPr/>
+        </p:nvSpPr>
+        <p:spPr>
+          <a:xfrm>
+            <a:off x="1828800" y="1097280"/>
+            <a:ext cx="1280160" cy="54864"/>
           </a:xfrm>
           <a:prstGeom prst="rect">
             <a:avLst/>
@@ -41739,14 +41859,14 @@
       </p:sp>
       <p:sp>
         <p:nvSpPr>
-          <p:cNvPr id="4" name="TextBox 3"/>
+          <p:cNvPr id="6" name="TextBox 5"/>
           <p:cNvSpPr txBox="1"/>
           <p:nvPr/>
         </p:nvSpPr>
         <p:spPr>
           <a:xfrm>
-            <a:off x="457200" y="1188720"/>
-            <a:ext cx="1517904" cy="2377440"/>
+            <a:off x="1828800" y="1188720"/>
+            <a:ext cx="1280160" cy="2377440"/>
           </a:xfrm>
           <a:prstGeom prst="rect">
             <a:avLst/>
@@ -41758,7 +41878,7 @@
         </p:spPr>
         <p:txBody>
           <a:bodyPr wrap="square" anchor="t" lIns="18288" tIns="54864" rIns="54864" bIns="36576">
-            <a:spAutoFit/>
+            <a:noAutofit/>
           </a:bodyPr>
           <a:lstStyle/>
           <a:p>
@@ -41769,7 +41889,7 @@
               <a:buNone/>
             </a:pPr>
             <a:r>
-              <a:rPr sz="850" b="1" i="0">
+              <a:rPr sz="800" b="1" i="0">
                 <a:solidFill>
                   <a:srgbClr val="6E6E6E"/>
                 </a:solidFill>
@@ -41786,7 +41906,7 @@
               <a:buNone/>
             </a:pPr>
             <a:r>
-              <a:rPr sz="1250" b="1" i="0">
+              <a:rPr sz="1150" b="1" i="0">
                 <a:solidFill>
                   <a:srgbClr val="1F1F1F"/>
                 </a:solidFill>
@@ -41803,27 +41923,27 @@
               <a:buNone/>
             </a:pPr>
             <a:r>
-              <a:rPr sz="950" b="0" i="0">
+              <a:rPr sz="900" b="0" i="0">
                 <a:solidFill>
                   <a:srgbClr val="4A4A4A"/>
                 </a:solidFill>
                 <a:latin typeface="Arial"/>
               </a:rPr>
-              <a:t>241 systems in 24 states from an existing spreadsheet plus supplemental California and Colorado lists. North Carolina service areas mapped by hand.</a:t>
-            </a:r>
-          </a:p>
-        </p:txBody>
-      </p:sp>
-      <p:sp>
-        <p:nvSpPr>
-          <p:cNvPr id="5" name="Rectangle 4"/>
+              <a:t>241 systems in 24 states from the NC work, an existing spreadsheet, and supplemental California and Colorado lists.</a:t>
+            </a:r>
+          </a:p>
+        </p:txBody>
+      </p:sp>
+      <p:sp>
+        <p:nvSpPr>
+          <p:cNvPr id="7" name="Rectangle 6"/>
           <p:cNvSpPr/>
           <p:nvPr/>
         </p:nvSpPr>
         <p:spPr>
           <a:xfrm>
-            <a:off x="2066543" y="1097280"/>
-            <a:ext cx="1517904" cy="54864"/>
+            <a:off x="3200400" y="1097280"/>
+            <a:ext cx="1280160" cy="54864"/>
           </a:xfrm>
           <a:prstGeom prst="rect">
             <a:avLst/>
@@ -41859,14 +41979,14 @@
       </p:sp>
       <p:sp>
         <p:nvSpPr>
-          <p:cNvPr id="6" name="TextBox 5"/>
+          <p:cNvPr id="8" name="TextBox 7"/>
           <p:cNvSpPr txBox="1"/>
           <p:nvPr/>
         </p:nvSpPr>
         <p:spPr>
           <a:xfrm>
-            <a:off x="2066543" y="1188720"/>
-            <a:ext cx="1517904" cy="2377440"/>
+            <a:off x="3200400" y="1188720"/>
+            <a:ext cx="1280160" cy="2377440"/>
           </a:xfrm>
           <a:prstGeom prst="rect">
             <a:avLst/>
@@ -41878,7 +41998,7 @@
         </p:spPr>
         <p:txBody>
           <a:bodyPr wrap="square" anchor="t" lIns="18288" tIns="54864" rIns="54864" bIns="36576">
-            <a:spAutoFit/>
+            <a:noAutofit/>
           </a:bodyPr>
           <a:lstStyle/>
           <a:p>
@@ -41889,7 +42009,7 @@
               <a:buNone/>
             </a:pPr>
             <a:r>
-              <a:rPr sz="850" b="1" i="0">
+              <a:rPr sz="800" b="1" i="0">
                 <a:solidFill>
                   <a:srgbClr val="0075BB"/>
                 </a:solidFill>
@@ -41906,7 +42026,7 @@
               <a:buNone/>
             </a:pPr>
             <a:r>
-              <a:rPr sz="1250" b="1" i="0">
+              <a:rPr sz="1150" b="1" i="0">
                 <a:solidFill>
                   <a:srgbClr val="1F1F1F"/>
                 </a:solidFill>
@@ -41923,7 +42043,7 @@
               <a:buNone/>
             </a:pPr>
             <a:r>
-              <a:rPr sz="950" b="0" i="0">
+              <a:rPr sz="900" b="0" i="0">
                 <a:solidFill>
                   <a:srgbClr val="4A4A4A"/>
                 </a:solidFill>
@@ -41936,14 +42056,14 @@
       </p:sp>
       <p:sp>
         <p:nvSpPr>
-          <p:cNvPr id="7" name="Rectangle 6"/>
+          <p:cNvPr id="9" name="Rectangle 8"/>
           <p:cNvSpPr/>
           <p:nvPr/>
         </p:nvSpPr>
         <p:spPr>
           <a:xfrm>
-            <a:off x="3675887" y="1097280"/>
-            <a:ext cx="1517904" cy="54864"/>
+            <a:off x="4572000" y="1097280"/>
+            <a:ext cx="1280160" cy="54864"/>
           </a:xfrm>
           <a:prstGeom prst="rect">
             <a:avLst/>
@@ -41979,14 +42099,14 @@
       </p:sp>
       <p:sp>
         <p:nvSpPr>
-          <p:cNvPr id="8" name="TextBox 7"/>
+          <p:cNvPr id="10" name="TextBox 9"/>
           <p:cNvSpPr txBox="1"/>
           <p:nvPr/>
         </p:nvSpPr>
         <p:spPr>
           <a:xfrm>
-            <a:off x="3675887" y="1188720"/>
-            <a:ext cx="1517904" cy="2377440"/>
+            <a:off x="4572000" y="1188720"/>
+            <a:ext cx="1280160" cy="2377440"/>
           </a:xfrm>
           <a:prstGeom prst="rect">
             <a:avLst/>
@@ -41998,7 +42118,7 @@
         </p:spPr>
         <p:txBody>
           <a:bodyPr wrap="square" anchor="t" lIns="18288" tIns="54864" rIns="54864" bIns="36576">
-            <a:spAutoFit/>
+            <a:noAutofit/>
           </a:bodyPr>
           <a:lstStyle/>
           <a:p>
@@ -42009,7 +42129,7 @@
               <a:buNone/>
             </a:pPr>
             <a:r>
-              <a:rPr sz="850" b="1" i="0">
+              <a:rPr sz="800" b="1" i="0">
                 <a:solidFill>
                   <a:srgbClr val="D57C5C"/>
                 </a:solidFill>
@@ -42026,7 +42146,7 @@
               <a:buNone/>
             </a:pPr>
             <a:r>
-              <a:rPr sz="1250" b="1" i="0">
+              <a:rPr sz="1150" b="1" i="0">
                 <a:solidFill>
                   <a:srgbClr val="1F1F1F"/>
                 </a:solidFill>
@@ -42043,7 +42163,7 @@
               <a:buNone/>
             </a:pPr>
             <a:r>
-              <a:rPr sz="950" b="0" i="0">
+              <a:rPr sz="900" b="0" i="0">
                 <a:solidFill>
                   <a:srgbClr val="4A4A4A"/>
                 </a:solidFill>
@@ -42056,14 +42176,14 @@
       </p:sp>
       <p:sp>
         <p:nvSpPr>
-          <p:cNvPr id="9" name="Rectangle 8"/>
+          <p:cNvPr id="11" name="Rectangle 10"/>
           <p:cNvSpPr/>
           <p:nvPr/>
         </p:nvSpPr>
         <p:spPr>
           <a:xfrm>
-            <a:off x="5285231" y="1097280"/>
-            <a:ext cx="1517904" cy="54864"/>
+            <a:off x="5943600" y="1097280"/>
+            <a:ext cx="1280160" cy="54864"/>
           </a:xfrm>
           <a:prstGeom prst="rect">
             <a:avLst/>
@@ -42099,14 +42219,14 @@
       </p:sp>
       <p:sp>
         <p:nvSpPr>
-          <p:cNvPr id="10" name="TextBox 9"/>
+          <p:cNvPr id="12" name="TextBox 11"/>
           <p:cNvSpPr txBox="1"/>
           <p:nvPr/>
         </p:nvSpPr>
         <p:spPr>
           <a:xfrm>
-            <a:off x="5285231" y="1188720"/>
-            <a:ext cx="1517904" cy="2377440"/>
+            <a:off x="5943600" y="1188720"/>
+            <a:ext cx="1280160" cy="2377440"/>
           </a:xfrm>
           <a:prstGeom prst="rect">
             <a:avLst/>
@@ -42118,7 +42238,7 @@
         </p:spPr>
         <p:txBody>
           <a:bodyPr wrap="square" anchor="t" lIns="18288" tIns="54864" rIns="54864" bIns="36576">
-            <a:spAutoFit/>
+            <a:noAutofit/>
           </a:bodyPr>
           <a:lstStyle/>
           <a:p>
@@ -42129,7 +42249,7 @@
               <a:buNone/>
             </a:pPr>
             <a:r>
-              <a:rPr sz="850" b="1" i="0">
+              <a:rPr sz="800" b="1" i="0">
                 <a:solidFill>
                   <a:srgbClr val="DB9728"/>
                 </a:solidFill>
@@ -42146,7 +42266,7 @@
               <a:buNone/>
             </a:pPr>
             <a:r>
-              <a:rPr sz="1250" b="1" i="0">
+              <a:rPr sz="1150" b="1" i="0">
                 <a:solidFill>
                   <a:srgbClr val="1F1F1F"/>
                 </a:solidFill>
@@ -42163,27 +42283,27 @@
               <a:buNone/>
             </a:pPr>
             <a:r>
-              <a:rPr sz="950" b="0" i="0">
+              <a:rPr sz="900" b="0" i="0">
                 <a:solidFill>
                   <a:srgbClr val="4A4A4A"/>
                 </a:solidFill>
                 <a:latin typeface="Arial"/>
               </a:rPr>
-              <a:t>Every advance-booking row re-checked against a primary source in 17 parallel state batches: 215 removed, about 40 corrected and kept, 64 flagged for a phone call.</a:t>
-            </a:r>
-          </a:p>
-        </p:txBody>
-      </p:sp>
-      <p:sp>
-        <p:nvSpPr>
-          <p:cNvPr id="11" name="Rectangle 10"/>
+              <a:t>Every advance-booking row re-checked against a primary source in 17 parallel state batches: 215 removed, about 40 corrected and kept, 64 flagged for follow-up.</a:t>
+            </a:r>
+          </a:p>
+        </p:txBody>
+      </p:sp>
+      <p:sp>
+        <p:nvSpPr>
+          <p:cNvPr id="13" name="Rectangle 12"/>
           <p:cNvSpPr/>
           <p:nvPr/>
         </p:nvSpPr>
         <p:spPr>
           <a:xfrm>
-            <a:off x="6894575" y="1097280"/>
-            <a:ext cx="1517904" cy="54864"/>
+            <a:off x="7315200" y="1097280"/>
+            <a:ext cx="1280160" cy="54864"/>
           </a:xfrm>
           <a:prstGeom prst="rect">
             <a:avLst/>
@@ -42219,14 +42339,14 @@
       </p:sp>
       <p:sp>
         <p:nvSpPr>
-          <p:cNvPr id="12" name="TextBox 11"/>
+          <p:cNvPr id="14" name="TextBox 13"/>
           <p:cNvSpPr txBox="1"/>
           <p:nvPr/>
         </p:nvSpPr>
         <p:spPr>
           <a:xfrm>
-            <a:off x="6894575" y="1188720"/>
-            <a:ext cx="1517904" cy="2377440"/>
+            <a:off x="7315200" y="1188720"/>
+            <a:ext cx="1280160" cy="2377440"/>
           </a:xfrm>
           <a:prstGeom prst="rect">
             <a:avLst/>
@@ -42238,7 +42358,7 @@
         </p:spPr>
         <p:txBody>
           <a:bodyPr wrap="square" anchor="t" lIns="18288" tIns="54864" rIns="54864" bIns="36576">
-            <a:spAutoFit/>
+            <a:noAutofit/>
           </a:bodyPr>
           <a:lstStyle/>
           <a:p>
@@ -42249,7 +42369,7 @@
               <a:buNone/>
             </a:pPr>
             <a:r>
-              <a:rPr sz="850" b="1" i="0">
+              <a:rPr sz="800" b="1" i="0">
                 <a:solidFill>
                   <a:srgbClr val="1A584D"/>
                 </a:solidFill>
@@ -42266,7 +42386,7 @@
               <a:buNone/>
             </a:pPr>
             <a:r>
-              <a:rPr sz="1250" b="1" i="0">
+              <a:rPr sz="1150" b="1" i="0">
                 <a:solidFill>
                   <a:srgbClr val="1F1F1F"/>
                 </a:solidFill>
@@ -42283,7 +42403,7 @@
               <a:buNone/>
             </a:pPr>
             <a:r>
-              <a:rPr sz="950" b="0" i="0">
+              <a:rPr sz="900" b="0" i="0">
                 <a:solidFill>
                   <a:srgbClr val="4A4A4A"/>
                 </a:solidFill>
@@ -42296,7 +42416,7 @@
       </p:sp>
       <p:sp>
         <p:nvSpPr>
-          <p:cNvPr id="13" name="TextBox 12"/>
+          <p:cNvPr id="15" name="TextBox 14"/>
           <p:cNvSpPr txBox="1"/>
           <p:nvPr/>
         </p:nvSpPr>
@@ -42317,7 +42437,7 @@
         </p:spPr>
         <p:txBody>
           <a:bodyPr wrap="square" anchor="ctr" lIns="109728" tIns="91440" rIns="109728" bIns="91440">
-            <a:spAutoFit/>
+            <a:noAutofit/>
           </a:bodyPr>
           <a:lstStyle/>
           <a:p>
@@ -42436,7 +42556,7 @@
         </p:spPr>
         <p:txBody>
           <a:bodyPr wrap="square" anchor="t" lIns="109728" tIns="91440" rIns="109728" bIns="91440">
-            <a:spAutoFit/>
+            <a:noAutofit/>
           </a:bodyPr>
           <a:lstStyle/>
           <a:p>
@@ -42487,7 +42607,7 @@
                 </a:solidFill>
                 <a:latin typeface="Arial"/>
               </a:rPr>
-              <a:t>Read what the CSV already has for a state, then search state DOT §5311 and §5310 provider rosters, NTD profiles and news for what is missing.</a:t>
+              <a:t>Read what the CSV already has for a state, then search state DOT §5311 and §5310 provider rosters, NTD profiles, press releases and local news coverage for what is missing.</a:t>
             </a:r>
           </a:p>
         </p:txBody>
@@ -42515,7 +42635,7 @@
         </p:spPr>
         <p:txBody>
           <a:bodyPr wrap="square" anchor="t" lIns="109728" tIns="91440" rIns="109728" bIns="91440">
-            <a:spAutoFit/>
+            <a:noAutofit/>
           </a:bodyPr>
           <a:lstStyle/>
           <a:p>
@@ -42566,7 +42686,7 @@
                 </a:solidFill>
                 <a:latin typeface="Arial"/>
               </a:rPr>
-              <a:t>Agency or operator page first. A row's own notes are never trusted for a scope call; bulk-imported text has been wrong before.</a:t>
+              <a:t>Agency or operator page first. News articles sometimes provide information that is not supported by operators.</a:t>
             </a:r>
           </a:p>
         </p:txBody>
@@ -42594,7 +42714,7 @@
         </p:spPr>
         <p:txBody>
           <a:bodyPr wrap="square" anchor="t" lIns="109728" tIns="91440" rIns="109728" bIns="91440">
-            <a:spAutoFit/>
+            <a:noAutofit/>
           </a:bodyPr>
           <a:lstStyle/>
           <a:p>
@@ -42673,7 +42793,7 @@
         </p:spPr>
         <p:txBody>
           <a:bodyPr wrap="square" anchor="t" lIns="109728" tIns="91440" rIns="109728" bIns="91440">
-            <a:spAutoFit/>
+            <a:noAutofit/>
           </a:bodyPr>
           <a:lstStyle/>
           <a:p>
@@ -42750,7 +42870,7 @@
         </p:spPr>
         <p:txBody>
           <a:bodyPr wrap="square" anchor="t" lIns="109728" tIns="91440" rIns="109728" bIns="91440">
-            <a:spAutoFit/>
+            <a:noAutofit/>
           </a:bodyPr>
           <a:lstStyle/>
           <a:p>
@@ -42810,7 +42930,7 @@
         </p:spPr>
         <p:txBody>
           <a:bodyPr wrap="square" anchor="t" lIns="109728" tIns="91440" rIns="109728" bIns="91440">
-            <a:spAutoFit/>
+            <a:noAutofit/>
           </a:bodyPr>
           <a:lstStyle/>
           <a:p>
@@ -43552,7 +43672,7 @@
         </p:spPr>
         <p:txBody>
           <a:bodyPr wrap="square" anchor="t" lIns="109728" tIns="91440" rIns="109728" bIns="91440">
-            <a:spAutoFit/>
+            <a:noAutofit/>
           </a:bodyPr>
           <a:lstStyle/>
           <a:p>
@@ -43992,7 +44112,7 @@
         </p:spPr>
         <p:txBody>
           <a:bodyPr wrap="square" anchor="t" lIns="109728" tIns="91440" rIns="109728" bIns="91440">
-            <a:spAutoFit/>
+            <a:noAutofit/>
           </a:bodyPr>
           <a:lstStyle/>
           <a:p>
@@ -44857,7 +44977,7 @@
         </p:spPr>
         <p:txBody>
           <a:bodyPr wrap="square" anchor="t" lIns="109728" tIns="91440" rIns="109728" bIns="91440">
-            <a:spAutoFit/>
+            <a:noAutofit/>
           </a:bodyPr>
           <a:lstStyle/>
           <a:p>

</xml_diff>

<commit_message>
Deck and dashboard: 'follow-up' instead of 'phone call'; Via reported as a count, not a share
Co-Authored-By: Claude Fable 5.1 <noreply@anthropic.com>
</commit_message>
<xml_diff>
--- a/docs/ODT-Database-Project-Summary.pptx
+++ b/docs/ODT-Database-Project-Summary.pptx
@@ -1745,7 +1745,7 @@
           <a:lstStyle/>
           <a:p>
             <a:r>
-              <a:t>Mention the Virginia DRPT toolkit example: one PDF had real vehicle specs for two FTA-funded pilots that no news coverage contained.</a:t>
+              <a:t>Mention the Virginia DRPT toolkit example: one PDF had real vehicle specs for two FTA-funded pilots that no news coverage contained. On vendors: Via is the most frequently identified platform, named outright on 134 systems, but the vendor is unrecorded for half the inventory, so quote counts, not market share.</a:t>
             </a:r>
           </a:p>
         </p:txBody>
@@ -38992,7 +38992,7 @@
                 </a:solidFill>
                 <a:latin typeface="Arial"/>
               </a:rPr>
-              <a:t>No web source states whether same-day is honored. Kept in scope and logged; each needs a phone call, not another search.</a:t>
+              <a:t>No web source states whether same-day is honored. Kept in scope and logged; each needs direct follow-up with the operator, not another web search.</a:t>
             </a:r>
           </a:p>
         </p:txBody>
@@ -40354,7 +40354,7 @@
                 </a:solidFill>
                 <a:latin typeface="Arial"/>
               </a:rPr>
-              <a:t>Phone confirmation of the 64 unconfirmed scheduling policies; agency zone maps for the six unmapped systems; FTA award lists as a discovery source.</a:t>
+              <a:t>Operator follow-up on the 64 unconfirmed scheduling policies; agency zone maps for the six unmapped systems; FTA award lists as a discovery source.</a:t>
             </a:r>
           </a:p>
           <a:p>

</xml_diff>